<commit_message>
GöAID: Pyramid-Folie verständlicher gerahmt (Rename every domain / Prove every login statt Projekt-Jargon)
</commit_message>
<xml_diff>
--- a/goaid/goaid-agentic-ai-in-practice.pptx
+++ b/goaid/goaid-agentic-ai-in-practice.pptx
@@ -2196,11 +2196,14 @@
             <a:r>
               <a:rPr lang="en-US" dirty="0"/>
               <a:t>notes:
-(2.5 min) Core slide — read the table column by column with ONE story
-each: column 1 = Case 1 (domain cutover), column 2 = Case 4 (SSO
-suite). Point out: all three levels live in git, not in heads or
-chats. Work becomes repeatable instead of heroic. Transition: "How do
-you get from this pyramid to a running workflow? → OpenSpec."</a:t>
+(2.5 min) Core slide. The two columns are two EVERYDAY scenarios,
+not project jargon: column 1 = a risky one-time change (we renamed
+all domains in production — Case 1), column 2 = proving a promise
+(login must work for all 15 services — Case 4, the 59-check SSO
+suite). Read the table row by row: same three levels, very different
+changes — that is why it is a method, not a trick. All levels live in
+git, not in heads or chats. Transition: "How do you get from this
+pyramid to a running workflow? → OpenSpec."</a:t>
             </a:r>
             <a:endParaRPr lang="en-US" dirty="0"/>
           </a:p>

</xml_diff>

<commit_message>
GöAID: SVG-Illustrationen (chat vs agent, Pyramide, agentflow-Pipeline); build.sh --allow-local-files sonst verwirft Marp lokale Bilder beim Export
</commit_message>
<xml_diff>
--- a/goaid/goaid-agentic-ai-in-practice.pptx
+++ b/goaid/goaid-agentic-ai-in-practice.pptx
@@ -1174,12 +1174,11 @@
             <a:r>
               <a:rPr lang="en-US" dirty="0"/>
               <a:t>notes:
-(1.5 min) Thin by design: drives git and any OpenAI-compatible agent
-CLI — default: pi. 71 tests, no network in CI. Demo path:
-af run --dry-run shows the dispatch plan, af status is the live
-board, af cost shows per-worker trust. Failure memory is underrated:
-retries list earlier errors so the agent does not repeat them.
-github.com/tobias-weiss-ai-xr/agentflow</a:t>
+(1.5 min) Walk the graphic: declarative tasks + workers, af fans out
+into isolated worktrees, every result passes a gate (exit 0) before
+merge; amber path = retry with error memory. UCB1 = workers earn
+trust by track record. Demo path: af run --dry-run, af status,
+af cost. github.com/tobias-weiss-ai-xr/agentflow</a:t>
             </a:r>
             <a:endParaRPr lang="en-US" dirty="0"/>
           </a:p>
@@ -1821,10 +1820,11 @@
             <a:r>
               <a:rPr lang="en-US" dirty="0"/>
               <a:t>notes:
-(1.5 min) Expectation management: agents are not finished bots. A
-model in a chat window cannot touch a file. The agent = model inside
-a frame that gives it tools and rules. Lesson from our courses:
-many expect "ready-made bots" — set that term straight here.</a:t>
+(1.5 min) Point at the graphic, don't read it. Left: chat = one
+question, one answer — the model cannot touch a file. Right: agent =
+goal → plan → tools → verify, inside a harness that gives tools and
+rules; the amber loop is where the work happens. Lesson from our
+courses: many expect "ready-made bots" — set that term straight here.</a:t>
             </a:r>
             <a:endParaRPr lang="en-US" dirty="0"/>
           </a:p>
@@ -2196,14 +2196,15 @@
             <a:r>
               <a:rPr lang="en-US" dirty="0"/>
               <a:t>notes:
-(2.5 min) Core slide. The two columns are two EVERYDAY scenarios,
-not project jargon: column 1 = a risky one-time change (we renamed
-all domains in production — Case 1), column 2 = proving a promise
-(login must work for all 15 services — Case 4, the 59-check SSO
-suite). Read the table row by row: same three levels, very different
-changes — that is why it is a method, not a trick. All levels live in
-git, not in heads or chats. Transition: "How do you get from this
-pyramid to a running workflow? → OpenSpec."</a:t>
+(2.5 min) Core slide. Pyramid: Spec (WHAT) on top, Contract (HOW)
+in the middle, Test (WHEN is it right) as the foundation. The two
+columns are two EVERYDAY scenarios, not project jargon: a risky
+one-time change (we renamed all domains in production — Case 1) and
+proving a promise (login must work for all 15 services — Case 4,
+the 59-check SSO suite). Read the table row by row: same three
+levels, very different changes — that is why it is a method, not a
+trick. All levels live in git, not in heads or chats. Transition:
+"How do you get from this pyramid to a running workflow? → OpenSpec."</a:t>
             </a:r>
             <a:endParaRPr lang="en-US" dirty="0"/>
           </a:p>

</xml_diff>